<commit_message>
updated schedule times ass
</commit_message>
<xml_diff>
--- a/unit-1-sem-2/paneltalk-1-calendar/calendar.pptx
+++ b/unit-1-sem-2/paneltalk-1-calendar/calendar.pptx
@@ -3550,7 +3550,7 @@
           </a:ln>
           <a:extLst>
             <a:ext uri="{C572A759-6A51-4108-AA02-DFA0A04FC94B}">
-              <ma14:wrappingTextBoxFlag xmlns:ma14="http://schemas.microsoft.com/office/mac/drawingml/2011/main" xmlns:a14="http://schemas.microsoft.com/office/drawing/2010/main" xmlns:m="http://schemas.openxmlformats.org/officeDocument/2006/math" xmlns="" val="1"/>
+              <ma14:wrappingTextBoxFlag xmlns="" xmlns:m="http://schemas.openxmlformats.org/officeDocument/2006/math" xmlns:a14="http://schemas.microsoft.com/office/drawing/2010/main" xmlns:ma14="http://schemas.microsoft.com/office/mac/drawingml/2011/main" val="1"/>
             </a:ext>
           </a:extLst>
         </p:spPr>
@@ -3587,7 +3587,7 @@
           </a:ln>
           <a:extLst>
             <a:ext uri="{C572A759-6A51-4108-AA02-DFA0A04FC94B}">
-              <ma14:wrappingTextBoxFlag xmlns:ma14="http://schemas.microsoft.com/office/mac/drawingml/2011/main" xmlns:a14="http://schemas.microsoft.com/office/drawing/2010/main" xmlns:m="http://schemas.openxmlformats.org/officeDocument/2006/math" xmlns="" val="1"/>
+              <ma14:wrappingTextBoxFlag xmlns="" xmlns:m="http://schemas.openxmlformats.org/officeDocument/2006/math" xmlns:a14="http://schemas.microsoft.com/office/drawing/2010/main" xmlns:ma14="http://schemas.microsoft.com/office/mac/drawingml/2011/main" val="1"/>
             </a:ext>
           </a:extLst>
         </p:spPr>
@@ -4457,7 +4457,7 @@
             </a:r>
             <a:r>
               <a:rPr lang="en-IE" dirty="0"/>
-              <a:t>5</a:t>
+              <a:t>6</a:t>
             </a:r>
             <a:endParaRPr dirty="0"/>
           </a:p>
@@ -4519,57 +4519,10 @@
       </p:pic>
       <p:pic>
         <p:nvPicPr>
-          <p:cNvPr id="1026" name="Picture 2" descr=" Higher Diploma in Computer Science 2025">
+          <p:cNvPr id="3" name="Picture 2" descr="A screenshot of a calendar&#10;&#10;AI-generated content may be incorrect.">
             <a:extLst>
               <a:ext uri="{FF2B5EF4-FFF2-40B4-BE49-F238E27FC236}">
-                <a16:creationId xmlns:a16="http://schemas.microsoft.com/office/drawing/2014/main" id="{6F84DC3A-3F5C-5E00-C867-5483A67B3B62}"/>
-              </a:ext>
-            </a:extLst>
-          </p:cNvPr>
-          <p:cNvPicPr>
-            <a:picLocks noChangeAspect="1" noChangeArrowheads="1"/>
-          </p:cNvPicPr>
-          <p:nvPr/>
-        </p:nvPicPr>
-        <p:blipFill>
-          <a:blip r:embed="rId4">
-            <a:extLst>
-              <a:ext uri="{28A0092B-C50C-407E-A947-70E740481C1C}">
-                <a14:useLocalDpi xmlns:a14="http://schemas.microsoft.com/office/drawing/2010/main" val="0"/>
-              </a:ext>
-            </a:extLst>
-          </a:blip>
-          <a:srcRect/>
-          <a:stretch>
-            <a:fillRect/>
-          </a:stretch>
-        </p:blipFill>
-        <p:spPr bwMode="auto">
-          <a:xfrm>
-            <a:off x="217784" y="3323967"/>
-            <a:ext cx="4098323" cy="4098323"/>
-          </a:xfrm>
-          <a:prstGeom prst="rect">
-            <a:avLst/>
-          </a:prstGeom>
-          <a:noFill/>
-          <a:extLst>
-            <a:ext uri="{909E8E84-426E-40DD-AFC4-6F175D3DCCD1}">
-              <a14:hiddenFill xmlns:a14="http://schemas.microsoft.com/office/drawing/2010/main">
-                <a:solidFill>
-                  <a:srgbClr val="FFFFFF"/>
-                </a:solidFill>
-              </a14:hiddenFill>
-            </a:ext>
-          </a:extLst>
-        </p:spPr>
-      </p:pic>
-      <p:pic>
-        <p:nvPicPr>
-          <p:cNvPr id="5" name="Picture 4">
-            <a:extLst>
-              <a:ext uri="{FF2B5EF4-FFF2-40B4-BE49-F238E27FC236}">
-                <a16:creationId xmlns:a16="http://schemas.microsoft.com/office/drawing/2014/main" id="{6D28CCC1-3BE7-ECFA-901A-AC62A82D0588}"/>
+                <a16:creationId xmlns:a16="http://schemas.microsoft.com/office/drawing/2014/main" id="{09E4FFA1-9069-2E36-4A5B-35DE7E24C4B8}"/>
               </a:ext>
             </a:extLst>
           </p:cNvPr>
@@ -4579,15 +4532,52 @@
           <p:nvPr/>
         </p:nvPicPr>
         <p:blipFill>
-          <a:blip r:embed="rId5"/>
+          <a:blip r:embed="rId4"/>
+          <a:srcRect t="2876" b="-1"/>
           <a:stretch>
             <a:fillRect/>
           </a:stretch>
         </p:blipFill>
         <p:spPr>
           <a:xfrm>
-            <a:off x="8120320" y="1124567"/>
-            <a:ext cx="15060956" cy="11466866"/>
+            <a:off x="8231420" y="1066800"/>
+            <a:ext cx="15934796" cy="11578413"/>
+          </a:xfrm>
+          <a:prstGeom prst="rect">
+            <a:avLst/>
+          </a:prstGeom>
+        </p:spPr>
+      </p:pic>
+      <p:pic>
+        <p:nvPicPr>
+          <p:cNvPr id="6" name="Picture 5" descr="A white numbers on an orange background&#10;&#10;AI-generated content may be incorrect.">
+            <a:extLst>
+              <a:ext uri="{FF2B5EF4-FFF2-40B4-BE49-F238E27FC236}">
+                <a16:creationId xmlns:a16="http://schemas.microsoft.com/office/drawing/2014/main" id="{246C1724-BD4D-768F-DE00-2AFF85B41742}"/>
+              </a:ext>
+            </a:extLst>
+          </p:cNvPr>
+          <p:cNvPicPr>
+            <a:picLocks noChangeAspect="1"/>
+          </p:cNvPicPr>
+          <p:nvPr/>
+        </p:nvPicPr>
+        <p:blipFill>
+          <a:blip r:embed="rId5">
+            <a:extLst>
+              <a:ext uri="{28A0092B-C50C-407E-A947-70E740481C1C}">
+                <a14:useLocalDpi xmlns:a14="http://schemas.microsoft.com/office/drawing/2010/main" val="0"/>
+              </a:ext>
+            </a:extLst>
+          </a:blip>
+          <a:stretch>
+            <a:fillRect/>
+          </a:stretch>
+        </p:blipFill>
+        <p:spPr>
+          <a:xfrm>
+            <a:off x="256890" y="2550238"/>
+            <a:ext cx="3983464" cy="3983464"/>
           </a:xfrm>
           <a:prstGeom prst="rect">
             <a:avLst/>
@@ -4640,7 +4630,7 @@
           </a:prstGeom>
           <a:extLst>
             <a:ext uri="{C572A759-6A51-4108-AA02-DFA0A04FC94B}">
-              <ma14:wrappingTextBoxFlag xmlns:ma14="http://schemas.microsoft.com/office/mac/drawingml/2011/main" xmlns:a14="http://schemas.microsoft.com/office/drawing/2010/main" xmlns:m="http://schemas.openxmlformats.org/officeDocument/2006/math" xmlns="" val="1"/>
+              <ma14:wrappingTextBoxFlag xmlns="" xmlns:m="http://schemas.openxmlformats.org/officeDocument/2006/math" xmlns:a14="http://schemas.microsoft.com/office/drawing/2010/main" xmlns:ma14="http://schemas.microsoft.com/office/mac/drawingml/2011/main" val="1"/>
             </a:ext>
           </a:extLst>
         </p:spPr>
@@ -4687,10 +4677,10 @@
       </p:sp>
       <p:pic>
         <p:nvPicPr>
-          <p:cNvPr id="3" name="Picture 2">
+          <p:cNvPr id="4" name="Picture 3" descr="A screenshot of a computer&#10;&#10;AI-generated content may be incorrect.">
             <a:extLst>
               <a:ext uri="{FF2B5EF4-FFF2-40B4-BE49-F238E27FC236}">
-                <a16:creationId xmlns:a16="http://schemas.microsoft.com/office/drawing/2014/main" id="{80475B3C-800A-3825-CB14-729C582D2497}"/>
+                <a16:creationId xmlns:a16="http://schemas.microsoft.com/office/drawing/2014/main" id="{2844BC03-53B4-23A0-2162-A4097AF8F7DF}"/>
               </a:ext>
             </a:extLst>
           </p:cNvPr>
@@ -4707,8 +4697,8 @@
         </p:blipFill>
         <p:spPr>
           <a:xfrm>
-            <a:off x="296085" y="2566981"/>
-            <a:ext cx="22272690" cy="7849763"/>
+            <a:off x="563220" y="3429000"/>
+            <a:ext cx="23645185" cy="6972299"/>
           </a:xfrm>
           <a:prstGeom prst="rect">
             <a:avLst/>
@@ -4790,7 +4780,7 @@
           </a:prstGeom>
           <a:extLst>
             <a:ext uri="{C572A759-6A51-4108-AA02-DFA0A04FC94B}">
-              <ma14:wrappingTextBoxFlag xmlns:ma14="http://schemas.microsoft.com/office/mac/drawingml/2011/main" xmlns:a14="http://schemas.microsoft.com/office/drawing/2010/main" xmlns:m="http://schemas.openxmlformats.org/officeDocument/2006/math" xmlns="" val="1"/>
+              <ma14:wrappingTextBoxFlag xmlns="" xmlns:m="http://schemas.openxmlformats.org/officeDocument/2006/math" xmlns:a14="http://schemas.microsoft.com/office/drawing/2010/main" xmlns:ma14="http://schemas.microsoft.com/office/mac/drawingml/2011/main" val="1"/>
             </a:ext>
           </a:extLst>
         </p:spPr>

</xml_diff>